<commit_message>
small changes to hierarchical tutorial
</commit_message>
<xml_diff>
--- a/Hierarchical/part1/sasview figure.pptx
+++ b/Hierarchical/part1/sasview figure.pptx
@@ -104,6 +104,11 @@
       </a:defRPr>
     </a:lvl9pPr>
   </p:defaultTextStyle>
+  <p:extLst>
+    <p:ext uri="{EFAFB233-063F-42B5-8137-9DF3F51BA10A}">
+      <p15:sldGuideLst xmlns:p15="http://schemas.microsoft.com/office/powerpoint/2012/main"/>
+    </p:ext>
+  </p:extLst>
 </p:presentation>
 </file>
 
@@ -256,7 +261,7 @@
           <a:p>
             <a:fld id="{2BED0363-3026-4CDF-906E-EF6732D712AE}" type="datetimeFigureOut">
               <a:rPr lang="en-US" smtClean="0"/>
-              <a:t>11/28/2025</a:t>
+              <a:t>7/30/26</a:t>
             </a:fld>
             <a:endParaRPr lang="en-US"/>
           </a:p>
@@ -310,7 +315,7 @@
           <a:p>
             <a:fld id="{A85AFFD1-739A-4498-BBAE-67ED8EA43711}" type="slidenum">
               <a:rPr lang="en-US" smtClean="0"/>
-              <a:t>‹nr.›</a:t>
+              <a:t>‹#›</a:t>
             </a:fld>
             <a:endParaRPr lang="en-US"/>
           </a:p>
@@ -456,7 +461,7 @@
           <a:p>
             <a:fld id="{2BED0363-3026-4CDF-906E-EF6732D712AE}" type="datetimeFigureOut">
               <a:rPr lang="en-US" smtClean="0"/>
-              <a:t>11/28/2025</a:t>
+              <a:t>7/30/26</a:t>
             </a:fld>
             <a:endParaRPr lang="en-US"/>
           </a:p>
@@ -510,7 +515,7 @@
           <a:p>
             <a:fld id="{A85AFFD1-739A-4498-BBAE-67ED8EA43711}" type="slidenum">
               <a:rPr lang="en-US" smtClean="0"/>
-              <a:t>‹nr.›</a:t>
+              <a:t>‹#›</a:t>
             </a:fld>
             <a:endParaRPr lang="en-US"/>
           </a:p>
@@ -666,7 +671,7 @@
           <a:p>
             <a:fld id="{2BED0363-3026-4CDF-906E-EF6732D712AE}" type="datetimeFigureOut">
               <a:rPr lang="en-US" smtClean="0"/>
-              <a:t>11/28/2025</a:t>
+              <a:t>7/30/26</a:t>
             </a:fld>
             <a:endParaRPr lang="en-US"/>
           </a:p>
@@ -720,7 +725,7 @@
           <a:p>
             <a:fld id="{A85AFFD1-739A-4498-BBAE-67ED8EA43711}" type="slidenum">
               <a:rPr lang="en-US" smtClean="0"/>
-              <a:t>‹nr.›</a:t>
+              <a:t>‹#›</a:t>
             </a:fld>
             <a:endParaRPr lang="en-US"/>
           </a:p>
@@ -866,7 +871,7 @@
           <a:p>
             <a:fld id="{2BED0363-3026-4CDF-906E-EF6732D712AE}" type="datetimeFigureOut">
               <a:rPr lang="en-US" smtClean="0"/>
-              <a:t>11/28/2025</a:t>
+              <a:t>7/30/26</a:t>
             </a:fld>
             <a:endParaRPr lang="en-US"/>
           </a:p>
@@ -920,7 +925,7 @@
           <a:p>
             <a:fld id="{A85AFFD1-739A-4498-BBAE-67ED8EA43711}" type="slidenum">
               <a:rPr lang="en-US" smtClean="0"/>
-              <a:t>‹nr.›</a:t>
+              <a:t>‹#›</a:t>
             </a:fld>
             <a:endParaRPr lang="en-US"/>
           </a:p>
@@ -1142,7 +1147,7 @@
           <a:p>
             <a:fld id="{2BED0363-3026-4CDF-906E-EF6732D712AE}" type="datetimeFigureOut">
               <a:rPr lang="en-US" smtClean="0"/>
-              <a:t>11/28/2025</a:t>
+              <a:t>7/30/26</a:t>
             </a:fld>
             <a:endParaRPr lang="en-US"/>
           </a:p>
@@ -1196,7 +1201,7 @@
           <a:p>
             <a:fld id="{A85AFFD1-739A-4498-BBAE-67ED8EA43711}" type="slidenum">
               <a:rPr lang="en-US" smtClean="0"/>
-              <a:t>‹nr.›</a:t>
+              <a:t>‹#›</a:t>
             </a:fld>
             <a:endParaRPr lang="en-US"/>
           </a:p>
@@ -1410,7 +1415,7 @@
           <a:p>
             <a:fld id="{2BED0363-3026-4CDF-906E-EF6732D712AE}" type="datetimeFigureOut">
               <a:rPr lang="en-US" smtClean="0"/>
-              <a:t>11/28/2025</a:t>
+              <a:t>7/30/26</a:t>
             </a:fld>
             <a:endParaRPr lang="en-US"/>
           </a:p>
@@ -1464,7 +1469,7 @@
           <a:p>
             <a:fld id="{A85AFFD1-739A-4498-BBAE-67ED8EA43711}" type="slidenum">
               <a:rPr lang="en-US" smtClean="0"/>
-              <a:t>‹nr.›</a:t>
+              <a:t>‹#›</a:t>
             </a:fld>
             <a:endParaRPr lang="en-US"/>
           </a:p>
@@ -1825,7 +1830,7 @@
           <a:p>
             <a:fld id="{2BED0363-3026-4CDF-906E-EF6732D712AE}" type="datetimeFigureOut">
               <a:rPr lang="en-US" smtClean="0"/>
-              <a:t>11/28/2025</a:t>
+              <a:t>7/30/26</a:t>
             </a:fld>
             <a:endParaRPr lang="en-US"/>
           </a:p>
@@ -1879,7 +1884,7 @@
           <a:p>
             <a:fld id="{A85AFFD1-739A-4498-BBAE-67ED8EA43711}" type="slidenum">
               <a:rPr lang="en-US" smtClean="0"/>
-              <a:t>‹nr.›</a:t>
+              <a:t>‹#›</a:t>
             </a:fld>
             <a:endParaRPr lang="en-US"/>
           </a:p>
@@ -1967,7 +1972,7 @@
           <a:p>
             <a:fld id="{2BED0363-3026-4CDF-906E-EF6732D712AE}" type="datetimeFigureOut">
               <a:rPr lang="en-US" smtClean="0"/>
-              <a:t>11/28/2025</a:t>
+              <a:t>7/30/26</a:t>
             </a:fld>
             <a:endParaRPr lang="en-US"/>
           </a:p>
@@ -2021,7 +2026,7 @@
           <a:p>
             <a:fld id="{A85AFFD1-739A-4498-BBAE-67ED8EA43711}" type="slidenum">
               <a:rPr lang="en-US" smtClean="0"/>
-              <a:t>‹nr.›</a:t>
+              <a:t>‹#›</a:t>
             </a:fld>
             <a:endParaRPr lang="en-US"/>
           </a:p>
@@ -2080,7 +2085,7 @@
           <a:p>
             <a:fld id="{2BED0363-3026-4CDF-906E-EF6732D712AE}" type="datetimeFigureOut">
               <a:rPr lang="en-US" smtClean="0"/>
-              <a:t>11/28/2025</a:t>
+              <a:t>7/30/26</a:t>
             </a:fld>
             <a:endParaRPr lang="en-US"/>
           </a:p>
@@ -2134,7 +2139,7 @@
           <a:p>
             <a:fld id="{A85AFFD1-739A-4498-BBAE-67ED8EA43711}" type="slidenum">
               <a:rPr lang="en-US" smtClean="0"/>
-              <a:t>‹nr.›</a:t>
+              <a:t>‹#›</a:t>
             </a:fld>
             <a:endParaRPr lang="en-US"/>
           </a:p>
@@ -2393,7 +2398,7 @@
           <a:p>
             <a:fld id="{2BED0363-3026-4CDF-906E-EF6732D712AE}" type="datetimeFigureOut">
               <a:rPr lang="en-US" smtClean="0"/>
-              <a:t>11/28/2025</a:t>
+              <a:t>7/30/26</a:t>
             </a:fld>
             <a:endParaRPr lang="en-US"/>
           </a:p>
@@ -2447,7 +2452,7 @@
           <a:p>
             <a:fld id="{A85AFFD1-739A-4498-BBAE-67ED8EA43711}" type="slidenum">
               <a:rPr lang="en-US" smtClean="0"/>
-              <a:t>‹nr.›</a:t>
+              <a:t>‹#›</a:t>
             </a:fld>
             <a:endParaRPr lang="en-US"/>
           </a:p>
@@ -2682,7 +2687,7 @@
           <a:p>
             <a:fld id="{2BED0363-3026-4CDF-906E-EF6732D712AE}" type="datetimeFigureOut">
               <a:rPr lang="en-US" smtClean="0"/>
-              <a:t>11/28/2025</a:t>
+              <a:t>7/30/26</a:t>
             </a:fld>
             <a:endParaRPr lang="en-US"/>
           </a:p>
@@ -2736,7 +2741,7 @@
           <a:p>
             <a:fld id="{A85AFFD1-739A-4498-BBAE-67ED8EA43711}" type="slidenum">
               <a:rPr lang="en-US" smtClean="0"/>
-              <a:t>‹nr.›</a:t>
+              <a:t>‹#›</a:t>
             </a:fld>
             <a:endParaRPr lang="en-US"/>
           </a:p>
@@ -2925,7 +2930,7 @@
           <a:p>
             <a:fld id="{2BED0363-3026-4CDF-906E-EF6732D712AE}" type="datetimeFigureOut">
               <a:rPr lang="en-US" smtClean="0"/>
-              <a:t>11/28/2025</a:t>
+              <a:t>7/30/26</a:t>
             </a:fld>
             <a:endParaRPr lang="en-US"/>
           </a:p>
@@ -3015,7 +3020,7 @@
           <a:p>
             <a:fld id="{A85AFFD1-739A-4498-BBAE-67ED8EA43711}" type="slidenum">
               <a:rPr lang="en-US" smtClean="0"/>
-              <a:t>‹nr.›</a:t>
+              <a:t>‹#›</a:t>
             </a:fld>
             <a:endParaRPr lang="en-US"/>
           </a:p>
@@ -4035,11 +4040,11 @@
           <a:lstStyle/>
           <a:p>
             <a:r>
-              <a:rPr lang="en-US" sz="1400" dirty="0" err="1"/>
+              <a:rPr lang="en-US" sz="1400" dirty="0"/>
               <a:t>R</a:t>
             </a:r>
             <a:r>
-              <a:rPr lang="en-US" sz="1400" baseline="-25000" dirty="0" err="1"/>
+              <a:rPr lang="en-US" sz="1400" baseline="-25000" dirty="0"/>
               <a:t>g</a:t>
             </a:r>
             <a:r>
@@ -4086,6 +4091,84 @@
           <a:p>
             <a:pPr algn="ctr"/>
             <a:endParaRPr lang="en-US" sz="1400" dirty="0"/>
+          </a:p>
+        </p:txBody>
+      </p:sp>
+      <p:sp>
+        <p:nvSpPr>
+          <p:cNvPr id="2" name="TextBox 1">
+            <a:extLst>
+              <a:ext uri="{FF2B5EF4-FFF2-40B4-BE49-F238E27FC236}">
+                <a16:creationId xmlns:a16="http://schemas.microsoft.com/office/drawing/2014/main" id="{91B466EE-F6EB-4257-D7CC-B3CBF2C4CDE8}"/>
+              </a:ext>
+            </a:extLst>
+          </p:cNvPr>
+          <p:cNvSpPr txBox="1"/>
+          <p:nvPr/>
+        </p:nvSpPr>
+        <p:spPr>
+          <a:xfrm>
+            <a:off x="8900389" y="1784049"/>
+            <a:ext cx="476092" cy="369332"/>
+          </a:xfrm>
+          <a:prstGeom prst="rect">
+            <a:avLst/>
+          </a:prstGeom>
+          <a:noFill/>
+        </p:spPr>
+        <p:txBody>
+          <a:bodyPr wrap="none" rtlCol="0">
+            <a:spAutoFit/>
+          </a:bodyPr>
+          <a:lstStyle/>
+          <a:p>
+            <a:r>
+              <a:rPr lang="en-US" dirty="0"/>
+              <a:t>Q</a:t>
+            </a:r>
+            <a:r>
+              <a:rPr lang="en-US" baseline="30000" dirty="0"/>
+              <a:t>-1</a:t>
+            </a:r>
+          </a:p>
+        </p:txBody>
+      </p:sp>
+      <p:sp>
+        <p:nvSpPr>
+          <p:cNvPr id="3" name="TextBox 2">
+            <a:extLst>
+              <a:ext uri="{FF2B5EF4-FFF2-40B4-BE49-F238E27FC236}">
+                <a16:creationId xmlns:a16="http://schemas.microsoft.com/office/drawing/2014/main" id="{35563A9D-A275-924C-6451-11B7415D35D3}"/>
+              </a:ext>
+            </a:extLst>
+          </p:cNvPr>
+          <p:cNvSpPr txBox="1"/>
+          <p:nvPr/>
+        </p:nvSpPr>
+        <p:spPr>
+          <a:xfrm>
+            <a:off x="10411444" y="3031719"/>
+            <a:ext cx="487634" cy="369332"/>
+          </a:xfrm>
+          <a:prstGeom prst="rect">
+            <a:avLst/>
+          </a:prstGeom>
+          <a:noFill/>
+        </p:spPr>
+        <p:txBody>
+          <a:bodyPr wrap="none" rtlCol="0">
+            <a:spAutoFit/>
+          </a:bodyPr>
+          <a:lstStyle/>
+          <a:p>
+            <a:r>
+              <a:rPr lang="en-US" dirty="0"/>
+              <a:t>Q</a:t>
+            </a:r>
+            <a:r>
+              <a:rPr lang="en-US" baseline="30000" dirty="0"/>
+              <a:t>-4</a:t>
+            </a:r>
           </a:p>
         </p:txBody>
       </p:sp>

</xml_diff>